<commit_message>
Finalize authoritative NetOracle submission
</commit_message>
<xml_diff>
--- a/world_model/Presentation SIH.pptx
+++ b/world_model/Presentation SIH.pptx
@@ -4677,7 +4677,7 @@
                 <a:ea typeface="Calibri" pitchFamily="34" charset="-122"/>
                 <a:cs typeface="Calibri" pitchFamily="34" charset="-120"/>
               </a:rPr>
-              <a:t>SHAP values + feature importance clarify why each forecast was made.</a:t>
+              <a:t>Gradient × Input feature attribution clarifies why each forecast was made.</a:t>
             </a:r>
             <a:endParaRPr lang="en-US" sz="1150" dirty="0"/>
           </a:p>
@@ -4997,7 +4997,7 @@
         <p:spPr>
           <a:xfrm>
             <a:off x="10520172" y="3968496"/>
-            <a:ext cx="731520" cy="365760"/>
+            <a:ext cx="1188720" cy="365760"/>
           </a:xfrm>
           <a:prstGeom prst="rect">
             <a:avLst/>
@@ -5021,7 +5021,7 @@
                 <a:ea typeface="Calibri" pitchFamily="34" charset="-122"/>
                 <a:cs typeface="Calibri" pitchFamily="34" charset="-120"/>
               </a:rPr>
-              <a:t>SHAP</a:t>
+              <a:t>Gradient × Input</a:t>
             </a:r>
             <a:endParaRPr lang="en-US" sz="1000" dirty="0"/>
           </a:p>
@@ -6859,7 +6859,7 @@
                             <a:srgbClr val="55636D"/>
                           </a:solidFill>
                         </a:rPr>
-                        <a:t>SHAP-based explainability</a:t>
+                        <a:t>Gradient × Input attribution</a:t>
                       </a:r>
                       <a:endParaRPr lang="en-US" sz="1050" dirty="0"/>
                     </a:p>
@@ -8438,7 +8438,7 @@
                 <a:ea typeface="Calibri" pitchFamily="34" charset="-122"/>
                 <a:cs typeface="Calibri" pitchFamily="34" charset="-120"/>
               </a:rPr>
-              <a:t>SHAP</a:t>
+              <a:t>Gradient × Input</a:t>
             </a:r>
             <a:endParaRPr lang="en-US" sz="1100" dirty="0"/>
           </a:p>

</xml_diff>